<commit_message>
finished plasma volume calculator to batch analyze. renamed some files and cleaned up folder
</commit_message>
<xml_diff>
--- a/Bremsstrahlung Measurements of VENUS 3rd-Generation ECR Ion Source.pptx
+++ b/Bremsstrahlung Measurements of VENUS 3rd-Generation ECR Ion Source.pptx
@@ -199,6 +199,452 @@
 </p:presentation>
 </file>
 
+<file path=ppt/charts/chart1.xml><?xml version="1.0" encoding="utf-8"?>
+<c:chartSpace xmlns:c="http://schemas.openxmlformats.org/drawingml/2006/chart" xmlns:a="http://schemas.openxmlformats.org/drawingml/2006/main" xmlns:r="http://schemas.openxmlformats.org/officeDocument/2006/relationships" xmlns:c16r2="http://schemas.microsoft.com/office/drawing/2015/06/chart">
+  <c:date1904 val="0"/>
+  <c:lang val="en-US"/>
+  <c:roundedCorners val="0"/>
+  <mc:AlternateContent xmlns:mc="http://schemas.openxmlformats.org/markup-compatibility/2006">
+    <mc:Choice xmlns:c14="http://schemas.microsoft.com/office/drawing/2007/8/2/chart" Requires="c14">
+      <c14:style val="102"/>
+    </mc:Choice>
+    <mc:Fallback>
+      <c:style val="2"/>
+    </mc:Fallback>
+  </mc:AlternateContent>
+  <c:chart>
+    <c:autoTitleDeleted val="0"/>
+    <c:plotArea>
+      <c:layout>
+        <c:manualLayout>
+          <c:layoutTarget val="inner"/>
+          <c:xMode val="edge"/>
+          <c:yMode val="edge"/>
+          <c:x val="0.1390439632545932"/>
+          <c:y val="6.5289442986293383E-2"/>
+          <c:w val="0.67329068241469892"/>
+          <c:h val="0.73444808982210552"/>
+        </c:manualLayout>
+      </c:layout>
+      <c:scatterChart>
+        <c:scatterStyle val="lineMarker"/>
+        <c:varyColors val="0"/>
+        <c:ser>
+          <c:idx val="0"/>
+          <c:order val="0"/>
+          <c:tx>
+            <c:v>1850W</c:v>
+          </c:tx>
+          <c:spPr>
+            <a:ln w="6350">
+              <a:solidFill>
+                <a:schemeClr val="accent2">
+                  <a:lumMod val="40000"/>
+                  <a:lumOff val="60000"/>
+                </a:schemeClr>
+              </a:solidFill>
+            </a:ln>
+          </c:spPr>
+          <c:marker>
+            <c:symbol val="circle"/>
+            <c:size val="7"/>
+            <c:spPr>
+              <a:solidFill>
+                <a:schemeClr val="accent2">
+                  <a:lumMod val="40000"/>
+                  <a:lumOff val="60000"/>
+                </a:schemeClr>
+              </a:solidFill>
+              <a:ln w="6350">
+                <a:solidFill>
+                  <a:schemeClr val="accent2">
+                    <a:lumMod val="40000"/>
+                    <a:lumOff val="60000"/>
+                  </a:schemeClr>
+                </a:solidFill>
+              </a:ln>
+            </c:spPr>
+          </c:marker>
+          <c:xVal>
+            <c:numRef>
+              <c:f>'C:\Users\intwa\Downloads\[microwaveLeakageTest5.xlsx]Sheet2'!$B$51:$B$54</c:f>
+              <c:numCache>
+                <c:formatCode>General</c:formatCode>
+                <c:ptCount val="4"/>
+                <c:pt idx="0">
+                  <c:v>11.333333333333334</c:v>
+                </c:pt>
+                <c:pt idx="1">
+                  <c:v>6.4</c:v>
+                </c:pt>
+                <c:pt idx="2">
+                  <c:v>8.2249999999999996</c:v>
+                </c:pt>
+                <c:pt idx="3">
+                  <c:v>5.166666666666667</c:v>
+                </c:pt>
+              </c:numCache>
+            </c:numRef>
+          </c:xVal>
+          <c:yVal>
+            <c:numRef>
+              <c:f>'C:\Users\intwa\Downloads\[microwaveLeakageTest5.xlsx]Sheet2'!$E$51:$E$54</c:f>
+              <c:numCache>
+                <c:formatCode>General</c:formatCode>
+                <c:ptCount val="4"/>
+                <c:pt idx="0">
+                  <c:v>1320</c:v>
+                </c:pt>
+                <c:pt idx="1">
+                  <c:v>1345</c:v>
+                </c:pt>
+                <c:pt idx="2">
+                  <c:v>1327</c:v>
+                </c:pt>
+                <c:pt idx="3">
+                  <c:v>1327</c:v>
+                </c:pt>
+              </c:numCache>
+            </c:numRef>
+          </c:yVal>
+          <c:smooth val="0"/>
+          <c:extLst>
+            <c:ext xmlns:c16="http://schemas.microsoft.com/office/drawing/2014/chart" uri="{C3380CC4-5D6E-409C-BE32-E72D297353CC}">
+              <c16:uniqueId val="{00000000-2512-4F8C-BDDB-7AF32B0C53BB}"/>
+            </c:ext>
+          </c:extLst>
+        </c:ser>
+        <c:ser>
+          <c:idx val="1"/>
+          <c:order val="1"/>
+          <c:tx>
+            <c:v>640W</c:v>
+          </c:tx>
+          <c:spPr>
+            <a:ln w="6350">
+              <a:solidFill>
+                <a:schemeClr val="accent2"/>
+              </a:solidFill>
+            </a:ln>
+          </c:spPr>
+          <c:marker>
+            <c:symbol val="circle"/>
+            <c:size val="7"/>
+            <c:spPr>
+              <a:solidFill>
+                <a:schemeClr val="accent2"/>
+              </a:solidFill>
+              <a:ln>
+                <a:solidFill>
+                  <a:schemeClr val="accent2"/>
+                </a:solidFill>
+              </a:ln>
+            </c:spPr>
+          </c:marker>
+          <c:xVal>
+            <c:numRef>
+              <c:f>'C:\Users\intwa\Downloads\[microwaveLeakageTest5.xlsx]Sheet2'!$B$55:$B$58</c:f>
+              <c:numCache>
+                <c:formatCode>General</c:formatCode>
+                <c:ptCount val="4"/>
+                <c:pt idx="0">
+                  <c:v>2.2000000000000002</c:v>
+                </c:pt>
+                <c:pt idx="1">
+                  <c:v>1.9090909090909092</c:v>
+                </c:pt>
+                <c:pt idx="2">
+                  <c:v>2.5555555555555554</c:v>
+                </c:pt>
+                <c:pt idx="3">
+                  <c:v>2.657142857142857</c:v>
+                </c:pt>
+              </c:numCache>
+            </c:numRef>
+          </c:xVal>
+          <c:yVal>
+            <c:numRef>
+              <c:f>'C:\Users\intwa\Downloads\[microwaveLeakageTest5.xlsx]Sheet2'!$E$55:$E$58</c:f>
+              <c:numCache>
+                <c:formatCode>General</c:formatCode>
+                <c:ptCount val="4"/>
+                <c:pt idx="0">
+                  <c:v>600</c:v>
+                </c:pt>
+                <c:pt idx="1">
+                  <c:v>590</c:v>
+                </c:pt>
+                <c:pt idx="2">
+                  <c:v>590</c:v>
+                </c:pt>
+                <c:pt idx="3">
+                  <c:v>590</c:v>
+                </c:pt>
+              </c:numCache>
+            </c:numRef>
+          </c:yVal>
+          <c:smooth val="0"/>
+          <c:extLst>
+            <c:ext xmlns:c16="http://schemas.microsoft.com/office/drawing/2014/chart" uri="{C3380CC4-5D6E-409C-BE32-E72D297353CC}">
+              <c16:uniqueId val="{00000001-2512-4F8C-BDDB-7AF32B0C53BB}"/>
+            </c:ext>
+          </c:extLst>
+        </c:ser>
+        <c:ser>
+          <c:idx val="2"/>
+          <c:order val="2"/>
+          <c:tx>
+            <c:v>1152W</c:v>
+          </c:tx>
+          <c:spPr>
+            <a:ln w="6350">
+              <a:solidFill>
+                <a:schemeClr val="accent2">
+                  <a:lumMod val="60000"/>
+                  <a:lumOff val="40000"/>
+                </a:schemeClr>
+              </a:solidFill>
+            </a:ln>
+          </c:spPr>
+          <c:marker>
+            <c:symbol val="circle"/>
+            <c:size val="7"/>
+            <c:spPr>
+              <a:solidFill>
+                <a:srgbClr val="EE2E57"/>
+              </a:solidFill>
+              <a:ln w="6350">
+                <a:solidFill>
+                  <a:srgbClr val="EE2E57"/>
+                </a:solidFill>
+              </a:ln>
+            </c:spPr>
+          </c:marker>
+          <c:xVal>
+            <c:numRef>
+              <c:f>'C:\Users\intwa\Downloads\[microwaveLeakageTest5.xlsx]Sheet2'!$B$59:$B$62</c:f>
+              <c:numCache>
+                <c:formatCode>General</c:formatCode>
+                <c:ptCount val="4"/>
+                <c:pt idx="0">
+                  <c:v>2.2000000000000002</c:v>
+                </c:pt>
+                <c:pt idx="1">
+                  <c:v>2.84</c:v>
+                </c:pt>
+                <c:pt idx="2">
+                  <c:v>4.7029702970297027</c:v>
+                </c:pt>
+                <c:pt idx="3">
+                  <c:v>6.5789473684210522</c:v>
+                </c:pt>
+              </c:numCache>
+            </c:numRef>
+          </c:xVal>
+          <c:yVal>
+            <c:numRef>
+              <c:f>'C:\Users\intwa\Downloads\[microwaveLeakageTest5.xlsx]Sheet2'!$E$59:$E$62</c:f>
+              <c:numCache>
+                <c:formatCode>General</c:formatCode>
+                <c:ptCount val="4"/>
+                <c:pt idx="0">
+                  <c:v>1020</c:v>
+                </c:pt>
+                <c:pt idx="1">
+                  <c:v>1015</c:v>
+                </c:pt>
+                <c:pt idx="2">
+                  <c:v>1015</c:v>
+                </c:pt>
+                <c:pt idx="3">
+                  <c:v>1013</c:v>
+                </c:pt>
+              </c:numCache>
+            </c:numRef>
+          </c:yVal>
+          <c:smooth val="0"/>
+          <c:extLst>
+            <c:ext xmlns:c16="http://schemas.microsoft.com/office/drawing/2014/chart" uri="{C3380CC4-5D6E-409C-BE32-E72D297353CC}">
+              <c16:uniqueId val="{00000002-2512-4F8C-BDDB-7AF32B0C53BB}"/>
+            </c:ext>
+          </c:extLst>
+        </c:ser>
+        <c:ser>
+          <c:idx val="3"/>
+          <c:order val="3"/>
+          <c:tx>
+            <c:v>1350W</c:v>
+          </c:tx>
+          <c:spPr>
+            <a:ln w="6350">
+              <a:solidFill>
+                <a:srgbClr val="C0504D">
+                  <a:lumMod val="75000"/>
+                </a:srgbClr>
+              </a:solidFill>
+            </a:ln>
+          </c:spPr>
+          <c:marker>
+            <c:symbol val="circle"/>
+            <c:size val="7"/>
+            <c:spPr>
+              <a:solidFill>
+                <a:schemeClr val="accent2">
+                  <a:lumMod val="75000"/>
+                </a:schemeClr>
+              </a:solidFill>
+              <a:ln>
+                <a:solidFill>
+                  <a:schemeClr val="accent2">
+                    <a:lumMod val="75000"/>
+                  </a:schemeClr>
+                </a:solidFill>
+              </a:ln>
+            </c:spPr>
+          </c:marker>
+          <c:xVal>
+            <c:numRef>
+              <c:f>'C:\Users\intwa\Downloads\[microwaveLeakageTest5.xlsx]Sheet2'!$B$63:$B$65</c:f>
+              <c:numCache>
+                <c:formatCode>General</c:formatCode>
+                <c:ptCount val="3"/>
+                <c:pt idx="0">
+                  <c:v>8</c:v>
+                </c:pt>
+                <c:pt idx="1">
+                  <c:v>12.5</c:v>
+                </c:pt>
+                <c:pt idx="2">
+                  <c:v>2.8571428571428572</c:v>
+                </c:pt>
+              </c:numCache>
+            </c:numRef>
+          </c:xVal>
+          <c:yVal>
+            <c:numRef>
+              <c:f>'C:\Users\intwa\Downloads\[microwaveLeakageTest5.xlsx]Sheet2'!$E$63:$E$65</c:f>
+              <c:numCache>
+                <c:formatCode>General</c:formatCode>
+                <c:ptCount val="3"/>
+                <c:pt idx="0">
+                  <c:v>1100</c:v>
+                </c:pt>
+                <c:pt idx="1">
+                  <c:v>1093</c:v>
+                </c:pt>
+                <c:pt idx="2">
+                  <c:v>1106</c:v>
+                </c:pt>
+              </c:numCache>
+            </c:numRef>
+          </c:yVal>
+          <c:smooth val="0"/>
+          <c:extLst>
+            <c:ext xmlns:c16="http://schemas.microsoft.com/office/drawing/2014/chart" uri="{C3380CC4-5D6E-409C-BE32-E72D297353CC}">
+              <c16:uniqueId val="{00000003-2512-4F8C-BDDB-7AF32B0C53BB}"/>
+            </c:ext>
+          </c:extLst>
+        </c:ser>
+        <c:dLbls>
+          <c:showLegendKey val="0"/>
+          <c:showVal val="0"/>
+          <c:showCatName val="0"/>
+          <c:showSerName val="0"/>
+          <c:showPercent val="0"/>
+          <c:showBubbleSize val="0"/>
+        </c:dLbls>
+        <c:axId val="89700608"/>
+        <c:axId val="89715456"/>
+      </c:scatterChart>
+      <c:valAx>
+        <c:axId val="89700608"/>
+        <c:scaling>
+          <c:orientation val="minMax"/>
+        </c:scaling>
+        <c:delete val="0"/>
+        <c:axPos val="b"/>
+        <c:title>
+          <c:tx>
+            <c:rich>
+              <a:bodyPr/>
+              <a:lstStyle/>
+              <a:p>
+                <a:pPr>
+                  <a:defRPr/>
+                </a:pPr>
+                <a:r>
+                  <a:rPr lang="en-US"/>
+                  <a:t>28/18 Power Ratio</a:t>
+                </a:r>
+              </a:p>
+            </c:rich>
+          </c:tx>
+          <c:overlay val="0"/>
+        </c:title>
+        <c:numFmt formatCode="General" sourceLinked="1"/>
+        <c:majorTickMark val="out"/>
+        <c:minorTickMark val="none"/>
+        <c:tickLblPos val="nextTo"/>
+        <c:crossAx val="89715456"/>
+        <c:crosses val="autoZero"/>
+        <c:crossBetween val="midCat"/>
+      </c:valAx>
+      <c:valAx>
+        <c:axId val="89715456"/>
+        <c:scaling>
+          <c:orientation val="minMax"/>
+        </c:scaling>
+        <c:delete val="0"/>
+        <c:axPos val="l"/>
+        <c:majorGridlines/>
+        <c:title>
+          <c:tx>
+            <c:rich>
+              <a:bodyPr rot="-5400000" vert="horz"/>
+              <a:lstStyle/>
+              <a:p>
+                <a:pPr>
+                  <a:defRPr/>
+                </a:pPr>
+                <a:r>
+                  <a:rPr lang="en-US"/>
+                  <a:t>O6+</a:t>
+                </a:r>
+              </a:p>
+            </c:rich>
+          </c:tx>
+          <c:overlay val="0"/>
+        </c:title>
+        <c:numFmt formatCode="General" sourceLinked="1"/>
+        <c:majorTickMark val="out"/>
+        <c:minorTickMark val="none"/>
+        <c:tickLblPos val="nextTo"/>
+        <c:crossAx val="89700608"/>
+        <c:crosses val="autoZero"/>
+        <c:crossBetween val="midCat"/>
+      </c:valAx>
+    </c:plotArea>
+    <c:legend>
+      <c:legendPos val="r"/>
+      <c:overlay val="0"/>
+    </c:legend>
+    <c:plotVisOnly val="1"/>
+    <c:dispBlanksAs val="gap"/>
+    <c:showDLblsOverMax val="0"/>
+  </c:chart>
+  <c:spPr>
+    <a:ln w="34925">
+      <a:solidFill>
+        <a:schemeClr val="accent2"/>
+      </a:solidFill>
+    </a:ln>
+  </c:spPr>
+  <c:externalData r:id="rId1">
+    <c:autoUpdate val="0"/>
+  </c:externalData>
+</c:chartSpace>
+</file>
+
 <file path=ppt/handoutMasters/handoutMaster1.xml><?xml version="1.0" encoding="utf-8"?>
 <p:handoutMaster xmlns:a="http://schemas.openxmlformats.org/drawingml/2006/main" xmlns:r="http://schemas.openxmlformats.org/officeDocument/2006/relationships" xmlns:p="http://schemas.openxmlformats.org/presentationml/2006/main">
   <p:cSld>
@@ -8899,6 +9345,469 @@
       </p:grpSpPr>
       <p:sp>
         <p:nvSpPr>
+          <p:cNvPr id="46" name="Text Placeholder 45">
+            <a:extLst>
+              <a:ext uri="{FF2B5EF4-FFF2-40B4-BE49-F238E27FC236}">
+                <a16:creationId xmlns:a16="http://schemas.microsoft.com/office/drawing/2014/main" id="{286114AB-30D5-D34A-B576-BF5D187AF412}"/>
+              </a:ext>
+            </a:extLst>
+          </p:cNvPr>
+          <p:cNvSpPr>
+            <a:spLocks noGrp="1"/>
+          </p:cNvSpPr>
+          <p:nvPr>
+            <p:ph type="body" sz="quarter" idx="11"/>
+          </p:nvPr>
+        </p:nvSpPr>
+        <p:spPr>
+          <a:xfrm>
+            <a:off x="635200" y="15525810"/>
+            <a:ext cx="6908601" cy="891334"/>
+          </a:xfrm>
+        </p:spPr>
+        <p:txBody>
+          <a:bodyPr/>
+          <a:lstStyle/>
+          <a:p>
+            <a:r>
+              <a:rPr lang="en-US" dirty="0"/>
+              <a:t>Introduction</a:t>
+            </a:r>
+          </a:p>
+        </p:txBody>
+      </p:sp>
+      <p:sp>
+        <p:nvSpPr>
+          <p:cNvPr id="47" name="Text Placeholder 46">
+            <a:extLst>
+              <a:ext uri="{FF2B5EF4-FFF2-40B4-BE49-F238E27FC236}">
+                <a16:creationId xmlns:a16="http://schemas.microsoft.com/office/drawing/2014/main" id="{5D056A5A-9064-4741-AE18-8DC417A52AF6}"/>
+              </a:ext>
+            </a:extLst>
+          </p:cNvPr>
+          <p:cNvSpPr>
+            <a:spLocks noGrp="1"/>
+          </p:cNvSpPr>
+          <p:nvPr>
+            <p:ph type="body" sz="quarter" idx="20"/>
+          </p:nvPr>
+        </p:nvSpPr>
+        <p:spPr/>
+        <p:txBody>
+          <a:bodyPr/>
+          <a:lstStyle/>
+          <a:p>
+            <a:r>
+              <a:rPr lang="en-US" dirty="0"/>
+              <a:t>Methodology</a:t>
+            </a:r>
+          </a:p>
+        </p:txBody>
+      </p:sp>
+      <p:sp>
+        <p:nvSpPr>
+          <p:cNvPr id="48" name="Text Placeholder 47">
+            <a:extLst>
+              <a:ext uri="{FF2B5EF4-FFF2-40B4-BE49-F238E27FC236}">
+                <a16:creationId xmlns:a16="http://schemas.microsoft.com/office/drawing/2014/main" id="{EE3DF84C-8A0A-2040-8842-5800319B346D}"/>
+              </a:ext>
+            </a:extLst>
+          </p:cNvPr>
+          <p:cNvSpPr>
+            <a:spLocks noGrp="1"/>
+          </p:cNvSpPr>
+          <p:nvPr>
+            <p:ph type="body" sz="quarter" idx="21"/>
+          </p:nvPr>
+        </p:nvSpPr>
+        <p:spPr>
+          <a:xfrm>
+            <a:off x="7966175" y="16613087"/>
+            <a:ext cx="12198751" cy="800197"/>
+          </a:xfrm>
+        </p:spPr>
+        <p:txBody>
+          <a:bodyPr/>
+          <a:lstStyle/>
+          <a:p>
+            <a:endParaRPr lang="en-US" dirty="0"/>
+          </a:p>
+        </p:txBody>
+      </p:sp>
+      <p:sp>
+        <p:nvSpPr>
+          <p:cNvPr id="49" name="Text Placeholder 48">
+            <a:extLst>
+              <a:ext uri="{FF2B5EF4-FFF2-40B4-BE49-F238E27FC236}">
+                <a16:creationId xmlns:a16="http://schemas.microsoft.com/office/drawing/2014/main" id="{F019DC3C-02A0-B140-9422-95A8BF7C064F}"/>
+              </a:ext>
+            </a:extLst>
+          </p:cNvPr>
+          <p:cNvSpPr>
+            <a:spLocks noGrp="1"/>
+          </p:cNvSpPr>
+          <p:nvPr>
+            <p:ph type="body" sz="quarter" idx="22"/>
+          </p:nvPr>
+        </p:nvSpPr>
+        <p:spPr>
+          <a:xfrm>
+            <a:off x="8011771" y="18811280"/>
+            <a:ext cx="14246124" cy="891334"/>
+          </a:xfrm>
+        </p:spPr>
+        <p:txBody>
+          <a:bodyPr/>
+          <a:lstStyle/>
+          <a:p>
+            <a:r>
+              <a:rPr lang="en-US" dirty="0"/>
+              <a:t>Power Ratio Results</a:t>
+            </a:r>
+          </a:p>
+        </p:txBody>
+      </p:sp>
+      <p:sp>
+        <p:nvSpPr>
+          <p:cNvPr id="50" name="Text Placeholder 49">
+            <a:extLst>
+              <a:ext uri="{FF2B5EF4-FFF2-40B4-BE49-F238E27FC236}">
+                <a16:creationId xmlns:a16="http://schemas.microsoft.com/office/drawing/2014/main" id="{E20E3472-4D95-F848-BA65-8A6EE060C235}"/>
+              </a:ext>
+            </a:extLst>
+          </p:cNvPr>
+          <p:cNvSpPr>
+            <a:spLocks noGrp="1"/>
+          </p:cNvSpPr>
+          <p:nvPr>
+            <p:ph type="body" sz="quarter" idx="23"/>
+          </p:nvPr>
+        </p:nvSpPr>
+        <p:spPr>
+          <a:xfrm>
+            <a:off x="7966174" y="30889399"/>
+            <a:ext cx="6908601" cy="830975"/>
+          </a:xfrm>
+        </p:spPr>
+        <p:txBody>
+          <a:bodyPr/>
+          <a:lstStyle/>
+          <a:p>
+            <a:endParaRPr lang="en-US" dirty="0"/>
+          </a:p>
+        </p:txBody>
+      </p:sp>
+      <p:sp>
+        <p:nvSpPr>
+          <p:cNvPr id="51" name="Text Placeholder 50">
+            <a:extLst>
+              <a:ext uri="{FF2B5EF4-FFF2-40B4-BE49-F238E27FC236}">
+                <a16:creationId xmlns:a16="http://schemas.microsoft.com/office/drawing/2014/main" id="{0A779AD3-032F-EB41-8895-AF29183B78D7}"/>
+              </a:ext>
+            </a:extLst>
+          </p:cNvPr>
+          <p:cNvSpPr>
+            <a:spLocks noGrp="1"/>
+          </p:cNvSpPr>
+          <p:nvPr>
+            <p:ph type="body" sz="quarter" idx="24"/>
+          </p:nvPr>
+        </p:nvSpPr>
+        <p:spPr>
+          <a:xfrm>
+            <a:off x="7966176" y="8019680"/>
+            <a:ext cx="21551586" cy="891334"/>
+          </a:xfrm>
+        </p:spPr>
+        <p:txBody>
+          <a:bodyPr/>
+          <a:lstStyle/>
+          <a:p>
+            <a:r>
+              <a:rPr lang="en-US" dirty="0"/>
+              <a:t>Experimental Setup</a:t>
+            </a:r>
+          </a:p>
+        </p:txBody>
+      </p:sp>
+      <p:sp>
+        <p:nvSpPr>
+          <p:cNvPr id="52" name="Text Placeholder 51">
+            <a:extLst>
+              <a:ext uri="{FF2B5EF4-FFF2-40B4-BE49-F238E27FC236}">
+                <a16:creationId xmlns:a16="http://schemas.microsoft.com/office/drawing/2014/main" id="{3C97E0B7-B816-8947-B695-D3F4DF9A1D0D}"/>
+              </a:ext>
+            </a:extLst>
+          </p:cNvPr>
+          <p:cNvSpPr>
+            <a:spLocks noGrp="1"/>
+          </p:cNvSpPr>
+          <p:nvPr>
+            <p:ph type="body" sz="quarter" idx="25"/>
+          </p:nvPr>
+        </p:nvSpPr>
+        <p:spPr>
+          <a:xfrm>
+            <a:off x="22698566" y="18818023"/>
+            <a:ext cx="6907325" cy="891334"/>
+          </a:xfrm>
+        </p:spPr>
+        <p:txBody>
+          <a:bodyPr/>
+          <a:lstStyle/>
+          <a:p>
+            <a:r>
+              <a:rPr lang="en-US" dirty="0"/>
+              <a:t>Conclusion</a:t>
+            </a:r>
+          </a:p>
+        </p:txBody>
+      </p:sp>
+      <p:sp>
+        <p:nvSpPr>
+          <p:cNvPr id="53" name="Text Placeholder 52">
+            <a:extLst>
+              <a:ext uri="{FF2B5EF4-FFF2-40B4-BE49-F238E27FC236}">
+                <a16:creationId xmlns:a16="http://schemas.microsoft.com/office/drawing/2014/main" id="{2C878CC6-AACC-9647-BA5F-D99707D05124}"/>
+              </a:ext>
+            </a:extLst>
+          </p:cNvPr>
+          <p:cNvSpPr>
+            <a:spLocks noGrp="1"/>
+          </p:cNvSpPr>
+          <p:nvPr>
+            <p:ph type="body" sz="quarter" idx="26"/>
+          </p:nvPr>
+        </p:nvSpPr>
+        <p:spPr>
+          <a:xfrm>
+            <a:off x="22635765" y="19868168"/>
+            <a:ext cx="6907325" cy="830975"/>
+          </a:xfrm>
+        </p:spPr>
+        <p:txBody>
+          <a:bodyPr/>
+          <a:lstStyle/>
+          <a:p>
+            <a:endParaRPr lang="en-US" dirty="0"/>
+          </a:p>
+        </p:txBody>
+      </p:sp>
+      <p:sp>
+        <p:nvSpPr>
+          <p:cNvPr id="54" name="Text Placeholder 53">
+            <a:extLst>
+              <a:ext uri="{FF2B5EF4-FFF2-40B4-BE49-F238E27FC236}">
+                <a16:creationId xmlns:a16="http://schemas.microsoft.com/office/drawing/2014/main" id="{CAD0C4E8-9E32-644D-9680-AB8E28EE55EA}"/>
+              </a:ext>
+            </a:extLst>
+          </p:cNvPr>
+          <p:cNvSpPr>
+            <a:spLocks noGrp="1"/>
+          </p:cNvSpPr>
+          <p:nvPr>
+            <p:ph type="body" sz="quarter" idx="27"/>
+          </p:nvPr>
+        </p:nvSpPr>
+        <p:spPr>
+          <a:xfrm>
+            <a:off x="22709256" y="24681262"/>
+            <a:ext cx="6907325" cy="891334"/>
+          </a:xfrm>
+        </p:spPr>
+        <p:txBody>
+          <a:bodyPr/>
+          <a:lstStyle/>
+          <a:p>
+            <a:r>
+              <a:rPr lang="en-US" dirty="0"/>
+              <a:t>Future Work</a:t>
+            </a:r>
+          </a:p>
+        </p:txBody>
+      </p:sp>
+      <p:sp>
+        <p:nvSpPr>
+          <p:cNvPr id="55" name="Text Placeholder 54">
+            <a:extLst>
+              <a:ext uri="{FF2B5EF4-FFF2-40B4-BE49-F238E27FC236}">
+                <a16:creationId xmlns:a16="http://schemas.microsoft.com/office/drawing/2014/main" id="{9753B3C2-4D25-7F41-BBC3-CF776DA4045F}"/>
+              </a:ext>
+            </a:extLst>
+          </p:cNvPr>
+          <p:cNvSpPr>
+            <a:spLocks noGrp="1"/>
+          </p:cNvSpPr>
+          <p:nvPr>
+            <p:ph type="body" sz="quarter" idx="28"/>
+          </p:nvPr>
+        </p:nvSpPr>
+        <p:spPr>
+          <a:xfrm>
+            <a:off x="22763375" y="25934181"/>
+            <a:ext cx="6853206" cy="830975"/>
+          </a:xfrm>
+        </p:spPr>
+        <p:txBody>
+          <a:bodyPr/>
+          <a:lstStyle/>
+          <a:p>
+            <a:endParaRPr lang="en-US" dirty="0"/>
+          </a:p>
+        </p:txBody>
+      </p:sp>
+      <p:sp>
+        <p:nvSpPr>
+          <p:cNvPr id="56" name="Text Placeholder 55">
+            <a:extLst>
+              <a:ext uri="{FF2B5EF4-FFF2-40B4-BE49-F238E27FC236}">
+                <a16:creationId xmlns:a16="http://schemas.microsoft.com/office/drawing/2014/main" id="{0C9FFCF2-4FCB-8A44-A58E-B7FA5F64CCC6}"/>
+              </a:ext>
+            </a:extLst>
+          </p:cNvPr>
+          <p:cNvSpPr>
+            <a:spLocks noGrp="1"/>
+          </p:cNvSpPr>
+          <p:nvPr>
+            <p:ph type="body" sz="quarter" idx="29"/>
+          </p:nvPr>
+        </p:nvSpPr>
+        <p:spPr>
+          <a:xfrm>
+            <a:off x="22635765" y="35717255"/>
+            <a:ext cx="6907325" cy="891334"/>
+          </a:xfrm>
+        </p:spPr>
+        <p:txBody>
+          <a:bodyPr/>
+          <a:lstStyle/>
+          <a:p>
+            <a:r>
+              <a:rPr lang="en-US" dirty="0"/>
+              <a:t>References</a:t>
+            </a:r>
+          </a:p>
+        </p:txBody>
+      </p:sp>
+      <p:sp>
+        <p:nvSpPr>
+          <p:cNvPr id="57" name="Text Placeholder 56">
+            <a:extLst>
+              <a:ext uri="{FF2B5EF4-FFF2-40B4-BE49-F238E27FC236}">
+                <a16:creationId xmlns:a16="http://schemas.microsoft.com/office/drawing/2014/main" id="{5CDC52D9-26D8-0B45-8C4B-7E40A410F011}"/>
+              </a:ext>
+            </a:extLst>
+          </p:cNvPr>
+          <p:cNvSpPr>
+            <a:spLocks noGrp="1"/>
+          </p:cNvSpPr>
+          <p:nvPr>
+            <p:ph type="body" sz="quarter" idx="30"/>
+          </p:nvPr>
+        </p:nvSpPr>
+        <p:spPr>
+          <a:xfrm>
+            <a:off x="22698566" y="37015300"/>
+            <a:ext cx="6910785" cy="830975"/>
+          </a:xfrm>
+        </p:spPr>
+        <p:txBody>
+          <a:bodyPr/>
+          <a:lstStyle/>
+          <a:p>
+            <a:endParaRPr lang="en-US" dirty="0"/>
+          </a:p>
+        </p:txBody>
+      </p:sp>
+      <p:sp>
+        <p:nvSpPr>
+          <p:cNvPr id="58" name="Text Placeholder 57">
+            <a:extLst>
+              <a:ext uri="{FF2B5EF4-FFF2-40B4-BE49-F238E27FC236}">
+                <a16:creationId xmlns:a16="http://schemas.microsoft.com/office/drawing/2014/main" id="{C19EA1CD-8D4D-E343-BC83-836468A253ED}"/>
+              </a:ext>
+            </a:extLst>
+          </p:cNvPr>
+          <p:cNvSpPr>
+            <a:spLocks noGrp="1"/>
+          </p:cNvSpPr>
+          <p:nvPr>
+            <p:ph type="body" sz="quarter" idx="96"/>
+          </p:nvPr>
+        </p:nvSpPr>
+        <p:spPr>
+          <a:xfrm>
+            <a:off x="621629" y="21268894"/>
+            <a:ext cx="6914059" cy="1138751"/>
+          </a:xfrm>
+        </p:spPr>
+        <p:txBody>
+          <a:bodyPr/>
+          <a:lstStyle/>
+          <a:p>
+            <a:r>
+              <a:rPr lang="en-US" dirty="0"/>
+              <a:t>Add diagram of set up of extraction beamline with distances</a:t>
+            </a:r>
+          </a:p>
+        </p:txBody>
+      </p:sp>
+      <p:sp>
+        <p:nvSpPr>
+          <p:cNvPr id="63" name="Picture Placeholder 62">
+            <a:extLst>
+              <a:ext uri="{FF2B5EF4-FFF2-40B4-BE49-F238E27FC236}">
+                <a16:creationId xmlns:a16="http://schemas.microsoft.com/office/drawing/2014/main" id="{9B2E9923-F9EF-A948-986F-9F3E04B8056B}"/>
+              </a:ext>
+            </a:extLst>
+          </p:cNvPr>
+          <p:cNvSpPr>
+            <a:spLocks noGrp="1"/>
+          </p:cNvSpPr>
+          <p:nvPr>
+            <p:ph type="pic" sz="quarter" idx="154"/>
+          </p:nvPr>
+        </p:nvSpPr>
+        <p:spPr/>
+      </p:sp>
+      <p:sp>
+        <p:nvSpPr>
+          <p:cNvPr id="64" name="Picture Placeholder 63">
+            <a:extLst>
+              <a:ext uri="{FF2B5EF4-FFF2-40B4-BE49-F238E27FC236}">
+                <a16:creationId xmlns:a16="http://schemas.microsoft.com/office/drawing/2014/main" id="{A0FD862B-3378-1A4D-B3F8-CAF99EA27905}"/>
+              </a:ext>
+            </a:extLst>
+          </p:cNvPr>
+          <p:cNvSpPr>
+            <a:spLocks noGrp="1"/>
+          </p:cNvSpPr>
+          <p:nvPr>
+            <p:ph type="pic" sz="quarter" idx="155"/>
+          </p:nvPr>
+        </p:nvSpPr>
+        <p:spPr/>
+      </p:sp>
+      <p:sp>
+        <p:nvSpPr>
+          <p:cNvPr id="65" name="Picture Placeholder 64">
+            <a:extLst>
+              <a:ext uri="{FF2B5EF4-FFF2-40B4-BE49-F238E27FC236}">
+                <a16:creationId xmlns:a16="http://schemas.microsoft.com/office/drawing/2014/main" id="{31C6CA46-52B1-4147-8928-196BB81D1982}"/>
+              </a:ext>
+            </a:extLst>
+          </p:cNvPr>
+          <p:cNvSpPr>
+            <a:spLocks noGrp="1"/>
+          </p:cNvSpPr>
+          <p:nvPr>
+            <p:ph type="pic" sz="quarter" idx="156"/>
+          </p:nvPr>
+        </p:nvSpPr>
+        <p:spPr/>
+      </p:sp>
+      <p:sp>
+        <p:nvSpPr>
           <p:cNvPr id="23" name="Text Placeholder 22">
             <a:extLst>
               <a:ext uri="{FF2B5EF4-FFF2-40B4-BE49-F238E27FC236}">
@@ -8913,7 +9822,12 @@
             <p:ph type="body" sz="quarter" idx="10"/>
           </p:nvPr>
         </p:nvSpPr>
-        <p:spPr/>
+        <p:spPr>
+          <a:xfrm>
+            <a:off x="657438" y="9206151"/>
+            <a:ext cx="6914059" cy="830975"/>
+          </a:xfrm>
+        </p:spPr>
         <p:txBody>
           <a:bodyPr/>
           <a:lstStyle/>
@@ -8921,485 +9835,6 @@
             <a:endParaRPr lang="en-US" dirty="0"/>
           </a:p>
         </p:txBody>
-      </p:sp>
-      <p:sp>
-        <p:nvSpPr>
-          <p:cNvPr id="46" name="Text Placeholder 45">
-            <a:extLst>
-              <a:ext uri="{FF2B5EF4-FFF2-40B4-BE49-F238E27FC236}">
-                <a16:creationId xmlns:a16="http://schemas.microsoft.com/office/drawing/2014/main" id="{286114AB-30D5-D34A-B576-BF5D187AF412}"/>
-              </a:ext>
-            </a:extLst>
-          </p:cNvPr>
-          <p:cNvSpPr>
-            <a:spLocks noGrp="1"/>
-          </p:cNvSpPr>
-          <p:nvPr>
-            <p:ph type="body" sz="quarter" idx="11"/>
-          </p:nvPr>
-        </p:nvSpPr>
-        <p:spPr/>
-        <p:txBody>
-          <a:bodyPr/>
-          <a:lstStyle/>
-          <a:p>
-            <a:r>
-              <a:rPr lang="en-US" dirty="0"/>
-              <a:t>Abstract</a:t>
-            </a:r>
-          </a:p>
-        </p:txBody>
-      </p:sp>
-      <p:sp>
-        <p:nvSpPr>
-          <p:cNvPr id="47" name="Text Placeholder 46">
-            <a:extLst>
-              <a:ext uri="{FF2B5EF4-FFF2-40B4-BE49-F238E27FC236}">
-                <a16:creationId xmlns:a16="http://schemas.microsoft.com/office/drawing/2014/main" id="{5D056A5A-9064-4741-AE18-8DC417A52AF6}"/>
-              </a:ext>
-            </a:extLst>
-          </p:cNvPr>
-          <p:cNvSpPr>
-            <a:spLocks noGrp="1"/>
-          </p:cNvSpPr>
-          <p:nvPr>
-            <p:ph type="body" sz="quarter" idx="20"/>
-          </p:nvPr>
-        </p:nvSpPr>
-        <p:spPr/>
-        <p:txBody>
-          <a:bodyPr/>
-          <a:lstStyle/>
-          <a:p>
-            <a:r>
-              <a:rPr lang="en-US" dirty="0"/>
-              <a:t>Methodology</a:t>
-            </a:r>
-          </a:p>
-        </p:txBody>
-      </p:sp>
-      <p:sp>
-        <p:nvSpPr>
-          <p:cNvPr id="48" name="Text Placeholder 47">
-            <a:extLst>
-              <a:ext uri="{FF2B5EF4-FFF2-40B4-BE49-F238E27FC236}">
-                <a16:creationId xmlns:a16="http://schemas.microsoft.com/office/drawing/2014/main" id="{EE3DF84C-8A0A-2040-8842-5800319B346D}"/>
-              </a:ext>
-            </a:extLst>
-          </p:cNvPr>
-          <p:cNvSpPr>
-            <a:spLocks noGrp="1"/>
-          </p:cNvSpPr>
-          <p:nvPr>
-            <p:ph type="body" sz="quarter" idx="21"/>
-          </p:nvPr>
-        </p:nvSpPr>
-        <p:spPr>
-          <a:xfrm>
-            <a:off x="7966175" y="16613087"/>
-            <a:ext cx="6908601" cy="1612727"/>
-          </a:xfrm>
-        </p:spPr>
-        <p:txBody>
-          <a:bodyPr/>
-          <a:lstStyle/>
-          <a:p>
-            <a:r>
-              <a:rPr lang="en-US" dirty="0"/>
-              <a:t>Data taken (should be two different boxes)</a:t>
-            </a:r>
-          </a:p>
-          <a:p>
-            <a:r>
-              <a:rPr lang="en-US" dirty="0"/>
-              <a:t>Power ratios</a:t>
-            </a:r>
-          </a:p>
-          <a:p>
-            <a:r>
-              <a:rPr lang="en-US" dirty="0"/>
-              <a:t>Magnet field changes</a:t>
-            </a:r>
-          </a:p>
-        </p:txBody>
-      </p:sp>
-      <p:sp>
-        <p:nvSpPr>
-          <p:cNvPr id="49" name="Text Placeholder 48">
-            <a:extLst>
-              <a:ext uri="{FF2B5EF4-FFF2-40B4-BE49-F238E27FC236}">
-                <a16:creationId xmlns:a16="http://schemas.microsoft.com/office/drawing/2014/main" id="{F019DC3C-02A0-B140-9422-95A8BF7C064F}"/>
-              </a:ext>
-            </a:extLst>
-          </p:cNvPr>
-          <p:cNvSpPr>
-            <a:spLocks noGrp="1"/>
-          </p:cNvSpPr>
-          <p:nvPr>
-            <p:ph type="body" sz="quarter" idx="22"/>
-          </p:nvPr>
-        </p:nvSpPr>
-        <p:spPr>
-          <a:xfrm>
-            <a:off x="7966176" y="15488973"/>
-            <a:ext cx="6908601" cy="891334"/>
-          </a:xfrm>
-        </p:spPr>
-        <p:txBody>
-          <a:bodyPr/>
-          <a:lstStyle/>
-          <a:p>
-            <a:r>
-              <a:rPr lang="en-US" dirty="0"/>
-              <a:t>Results</a:t>
-            </a:r>
-          </a:p>
-        </p:txBody>
-      </p:sp>
-      <p:sp>
-        <p:nvSpPr>
-          <p:cNvPr id="50" name="Text Placeholder 49">
-            <a:extLst>
-              <a:ext uri="{FF2B5EF4-FFF2-40B4-BE49-F238E27FC236}">
-                <a16:creationId xmlns:a16="http://schemas.microsoft.com/office/drawing/2014/main" id="{E20E3472-4D95-F848-BA65-8A6EE060C235}"/>
-              </a:ext>
-            </a:extLst>
-          </p:cNvPr>
-          <p:cNvSpPr>
-            <a:spLocks noGrp="1"/>
-          </p:cNvSpPr>
-          <p:nvPr>
-            <p:ph type="body" sz="quarter" idx="23"/>
-          </p:nvPr>
-        </p:nvSpPr>
-        <p:spPr>
-          <a:xfrm>
-            <a:off x="15303699" y="20902723"/>
-            <a:ext cx="6908601" cy="830975"/>
-          </a:xfrm>
-        </p:spPr>
-        <p:txBody>
-          <a:bodyPr/>
-          <a:lstStyle/>
-          <a:p>
-            <a:endParaRPr lang="en-US" dirty="0"/>
-          </a:p>
-        </p:txBody>
-      </p:sp>
-      <p:sp>
-        <p:nvSpPr>
-          <p:cNvPr id="51" name="Text Placeholder 50">
-            <a:extLst>
-              <a:ext uri="{FF2B5EF4-FFF2-40B4-BE49-F238E27FC236}">
-                <a16:creationId xmlns:a16="http://schemas.microsoft.com/office/drawing/2014/main" id="{0A779AD3-032F-EB41-8895-AF29183B78D7}"/>
-              </a:ext>
-            </a:extLst>
-          </p:cNvPr>
-          <p:cNvSpPr>
-            <a:spLocks noGrp="1"/>
-          </p:cNvSpPr>
-          <p:nvPr>
-            <p:ph type="body" sz="quarter" idx="24"/>
-          </p:nvPr>
-        </p:nvSpPr>
-        <p:spPr>
-          <a:xfrm>
-            <a:off x="7966176" y="8019680"/>
-            <a:ext cx="14246124" cy="891334"/>
-          </a:xfrm>
-        </p:spPr>
-        <p:txBody>
-          <a:bodyPr/>
-          <a:lstStyle/>
-          <a:p>
-            <a:r>
-              <a:rPr lang="en-US" dirty="0"/>
-              <a:t>Experimental Setup</a:t>
-            </a:r>
-          </a:p>
-        </p:txBody>
-      </p:sp>
-      <p:sp>
-        <p:nvSpPr>
-          <p:cNvPr id="52" name="Text Placeholder 51">
-            <a:extLst>
-              <a:ext uri="{FF2B5EF4-FFF2-40B4-BE49-F238E27FC236}">
-                <a16:creationId xmlns:a16="http://schemas.microsoft.com/office/drawing/2014/main" id="{3C97E0B7-B816-8947-B695-D3F4DF9A1D0D}"/>
-              </a:ext>
-            </a:extLst>
-          </p:cNvPr>
-          <p:cNvSpPr>
-            <a:spLocks noGrp="1"/>
-          </p:cNvSpPr>
-          <p:nvPr>
-            <p:ph type="body" sz="quarter" idx="25"/>
-          </p:nvPr>
-        </p:nvSpPr>
-        <p:spPr/>
-        <p:txBody>
-          <a:bodyPr/>
-          <a:lstStyle/>
-          <a:p>
-            <a:r>
-              <a:rPr lang="en-US" dirty="0"/>
-              <a:t>Conclusion</a:t>
-            </a:r>
-          </a:p>
-        </p:txBody>
-      </p:sp>
-      <p:sp>
-        <p:nvSpPr>
-          <p:cNvPr id="53" name="Text Placeholder 52">
-            <a:extLst>
-              <a:ext uri="{FF2B5EF4-FFF2-40B4-BE49-F238E27FC236}">
-                <a16:creationId xmlns:a16="http://schemas.microsoft.com/office/drawing/2014/main" id="{2C878CC6-AACC-9647-BA5F-D99707D05124}"/>
-              </a:ext>
-            </a:extLst>
-          </p:cNvPr>
-          <p:cNvSpPr>
-            <a:spLocks noGrp="1"/>
-          </p:cNvSpPr>
-          <p:nvPr>
-            <p:ph type="body" sz="quarter" idx="26"/>
-          </p:nvPr>
-        </p:nvSpPr>
-        <p:spPr/>
-        <p:txBody>
-          <a:bodyPr/>
-          <a:lstStyle/>
-          <a:p>
-            <a:endParaRPr lang="en-US"/>
-          </a:p>
-        </p:txBody>
-      </p:sp>
-      <p:sp>
-        <p:nvSpPr>
-          <p:cNvPr id="54" name="Text Placeholder 53">
-            <a:extLst>
-              <a:ext uri="{FF2B5EF4-FFF2-40B4-BE49-F238E27FC236}">
-                <a16:creationId xmlns:a16="http://schemas.microsoft.com/office/drawing/2014/main" id="{CAD0C4E8-9E32-644D-9680-AB8E28EE55EA}"/>
-              </a:ext>
-            </a:extLst>
-          </p:cNvPr>
-          <p:cNvSpPr>
-            <a:spLocks noGrp="1"/>
-          </p:cNvSpPr>
-          <p:nvPr>
-            <p:ph type="body" sz="quarter" idx="27"/>
-          </p:nvPr>
-        </p:nvSpPr>
-        <p:spPr/>
-        <p:txBody>
-          <a:bodyPr/>
-          <a:lstStyle/>
-          <a:p>
-            <a:r>
-              <a:rPr lang="en-US" dirty="0"/>
-              <a:t>Future Work</a:t>
-            </a:r>
-          </a:p>
-        </p:txBody>
-      </p:sp>
-      <p:sp>
-        <p:nvSpPr>
-          <p:cNvPr id="55" name="Text Placeholder 54">
-            <a:extLst>
-              <a:ext uri="{FF2B5EF4-FFF2-40B4-BE49-F238E27FC236}">
-                <a16:creationId xmlns:a16="http://schemas.microsoft.com/office/drawing/2014/main" id="{9753B3C2-4D25-7F41-BBC3-CF776DA4045F}"/>
-              </a:ext>
-            </a:extLst>
-          </p:cNvPr>
-          <p:cNvSpPr>
-            <a:spLocks noGrp="1"/>
-          </p:cNvSpPr>
-          <p:nvPr>
-            <p:ph type="body" sz="quarter" idx="28"/>
-          </p:nvPr>
-        </p:nvSpPr>
-        <p:spPr/>
-        <p:txBody>
-          <a:bodyPr/>
-          <a:lstStyle/>
-          <a:p>
-            <a:endParaRPr lang="en-US"/>
-          </a:p>
-        </p:txBody>
-      </p:sp>
-      <p:sp>
-        <p:nvSpPr>
-          <p:cNvPr id="56" name="Text Placeholder 55">
-            <a:extLst>
-              <a:ext uri="{FF2B5EF4-FFF2-40B4-BE49-F238E27FC236}">
-                <a16:creationId xmlns:a16="http://schemas.microsoft.com/office/drawing/2014/main" id="{0C9FFCF2-4FCB-8A44-A58E-B7FA5F64CCC6}"/>
-              </a:ext>
-            </a:extLst>
-          </p:cNvPr>
-          <p:cNvSpPr>
-            <a:spLocks noGrp="1"/>
-          </p:cNvSpPr>
-          <p:nvPr>
-            <p:ph type="body" sz="quarter" idx="29"/>
-          </p:nvPr>
-        </p:nvSpPr>
-        <p:spPr/>
-        <p:txBody>
-          <a:bodyPr/>
-          <a:lstStyle/>
-          <a:p>
-            <a:r>
-              <a:rPr lang="en-US" dirty="0"/>
-              <a:t>References</a:t>
-            </a:r>
-          </a:p>
-        </p:txBody>
-      </p:sp>
-      <p:sp>
-        <p:nvSpPr>
-          <p:cNvPr id="57" name="Text Placeholder 56">
-            <a:extLst>
-              <a:ext uri="{FF2B5EF4-FFF2-40B4-BE49-F238E27FC236}">
-                <a16:creationId xmlns:a16="http://schemas.microsoft.com/office/drawing/2014/main" id="{5CDC52D9-26D8-0B45-8C4B-7E40A410F011}"/>
-              </a:ext>
-            </a:extLst>
-          </p:cNvPr>
-          <p:cNvSpPr>
-            <a:spLocks noGrp="1"/>
-          </p:cNvSpPr>
-          <p:nvPr>
-            <p:ph type="body" sz="quarter" idx="30"/>
-          </p:nvPr>
-        </p:nvSpPr>
-        <p:spPr/>
-        <p:txBody>
-          <a:bodyPr/>
-          <a:lstStyle/>
-          <a:p>
-            <a:endParaRPr lang="en-US" dirty="0"/>
-          </a:p>
-        </p:txBody>
-      </p:sp>
-      <p:sp>
-        <p:nvSpPr>
-          <p:cNvPr id="58" name="Text Placeholder 57">
-            <a:extLst>
-              <a:ext uri="{FF2B5EF4-FFF2-40B4-BE49-F238E27FC236}">
-                <a16:creationId xmlns:a16="http://schemas.microsoft.com/office/drawing/2014/main" id="{C19EA1CD-8D4D-E343-BC83-836468A253ED}"/>
-              </a:ext>
-            </a:extLst>
-          </p:cNvPr>
-          <p:cNvSpPr>
-            <a:spLocks noGrp="1"/>
-          </p:cNvSpPr>
-          <p:nvPr>
-            <p:ph type="body" sz="quarter" idx="96"/>
-          </p:nvPr>
-        </p:nvSpPr>
-        <p:spPr>
-          <a:xfrm>
-            <a:off x="621629" y="21268894"/>
-            <a:ext cx="6914059" cy="1138751"/>
-          </a:xfrm>
-        </p:spPr>
-        <p:txBody>
-          <a:bodyPr/>
-          <a:lstStyle/>
-          <a:p>
-            <a:r>
-              <a:rPr lang="en-US" dirty="0"/>
-              <a:t>Add diagram of set up of extraction beamline with distances</a:t>
-            </a:r>
-          </a:p>
-        </p:txBody>
-      </p:sp>
-      <p:sp>
-        <p:nvSpPr>
-          <p:cNvPr id="61" name="Picture Placeholder 60">
-            <a:extLst>
-              <a:ext uri="{FF2B5EF4-FFF2-40B4-BE49-F238E27FC236}">
-                <a16:creationId xmlns:a16="http://schemas.microsoft.com/office/drawing/2014/main" id="{AC480137-4287-D34E-82E7-F6FC3ACF6E65}"/>
-              </a:ext>
-            </a:extLst>
-          </p:cNvPr>
-          <p:cNvSpPr>
-            <a:spLocks noGrp="1"/>
-          </p:cNvSpPr>
-          <p:nvPr>
-            <p:ph type="pic" sz="quarter" idx="152"/>
-          </p:nvPr>
-        </p:nvSpPr>
-        <p:spPr/>
-      </p:sp>
-      <p:sp>
-        <p:nvSpPr>
-          <p:cNvPr id="62" name="Picture Placeholder 61">
-            <a:extLst>
-              <a:ext uri="{FF2B5EF4-FFF2-40B4-BE49-F238E27FC236}">
-                <a16:creationId xmlns:a16="http://schemas.microsoft.com/office/drawing/2014/main" id="{4D825008-AEB6-BC48-95EB-6D98C30AD66B}"/>
-              </a:ext>
-            </a:extLst>
-          </p:cNvPr>
-          <p:cNvSpPr>
-            <a:spLocks noGrp="1"/>
-          </p:cNvSpPr>
-          <p:nvPr>
-            <p:ph type="pic" sz="quarter" idx="153"/>
-          </p:nvPr>
-        </p:nvSpPr>
-        <p:spPr/>
-      </p:sp>
-      <p:sp>
-        <p:nvSpPr>
-          <p:cNvPr id="63" name="Picture Placeholder 62">
-            <a:extLst>
-              <a:ext uri="{FF2B5EF4-FFF2-40B4-BE49-F238E27FC236}">
-                <a16:creationId xmlns:a16="http://schemas.microsoft.com/office/drawing/2014/main" id="{9B2E9923-F9EF-A948-986F-9F3E04B8056B}"/>
-              </a:ext>
-            </a:extLst>
-          </p:cNvPr>
-          <p:cNvSpPr>
-            <a:spLocks noGrp="1"/>
-          </p:cNvSpPr>
-          <p:nvPr>
-            <p:ph type="pic" sz="quarter" idx="154"/>
-          </p:nvPr>
-        </p:nvSpPr>
-        <p:spPr/>
-      </p:sp>
-      <p:sp>
-        <p:nvSpPr>
-          <p:cNvPr id="64" name="Picture Placeholder 63">
-            <a:extLst>
-              <a:ext uri="{FF2B5EF4-FFF2-40B4-BE49-F238E27FC236}">
-                <a16:creationId xmlns:a16="http://schemas.microsoft.com/office/drawing/2014/main" id="{A0FD862B-3378-1A4D-B3F8-CAF99EA27905}"/>
-              </a:ext>
-            </a:extLst>
-          </p:cNvPr>
-          <p:cNvSpPr>
-            <a:spLocks noGrp="1"/>
-          </p:cNvSpPr>
-          <p:nvPr>
-            <p:ph type="pic" sz="quarter" idx="155"/>
-          </p:nvPr>
-        </p:nvSpPr>
-        <p:spPr/>
-      </p:sp>
-      <p:sp>
-        <p:nvSpPr>
-          <p:cNvPr id="65" name="Picture Placeholder 64">
-            <a:extLst>
-              <a:ext uri="{FF2B5EF4-FFF2-40B4-BE49-F238E27FC236}">
-                <a16:creationId xmlns:a16="http://schemas.microsoft.com/office/drawing/2014/main" id="{31C6CA46-52B1-4147-8928-196BB81D1982}"/>
-              </a:ext>
-            </a:extLst>
-          </p:cNvPr>
-          <p:cNvSpPr>
-            <a:spLocks noGrp="1"/>
-          </p:cNvSpPr>
-          <p:nvPr>
-            <p:ph type="pic" sz="quarter" idx="156"/>
-          </p:nvPr>
-        </p:nvSpPr>
-        <p:spPr/>
       </p:sp>
       <p:sp>
         <p:nvSpPr>
@@ -9544,196 +9979,6 @@
       </p:sp>
       <p:sp>
         <p:nvSpPr>
-          <p:cNvPr id="6" name="Text Placeholder 48">
-            <a:extLst>
-              <a:ext uri="{FF2B5EF4-FFF2-40B4-BE49-F238E27FC236}">
-                <a16:creationId xmlns:a16="http://schemas.microsoft.com/office/drawing/2014/main" id="{C919C9ED-6E42-05BE-EBA0-DCC694E63F69}"/>
-              </a:ext>
-            </a:extLst>
-          </p:cNvPr>
-          <p:cNvSpPr txBox="1">
-            <a:spLocks/>
-          </p:cNvSpPr>
-          <p:nvPr/>
-        </p:nvSpPr>
-        <p:spPr>
-          <a:xfrm>
-            <a:off x="15300425" y="15488973"/>
-            <a:ext cx="6908601" cy="891334"/>
-          </a:xfrm>
-          <a:prstGeom prst="rect">
-            <a:avLst/>
-          </a:prstGeom>
-          <a:solidFill>
-            <a:schemeClr val="accent1"/>
-          </a:solidFill>
-        </p:spPr>
-        <p:txBody>
-          <a:bodyPr lIns="182880" tIns="182880" rIns="182880" bIns="182880" anchor="ctr" anchorCtr="0">
-            <a:spAutoFit/>
-          </a:bodyPr>
-          <a:lstStyle>
-            <a:lvl1pPr marL="1507651" indent="-1507651" algn="ctr" defTabSz="4022342" rtl="0" eaLnBrk="1" fontAlgn="base" hangingPunct="1">
-              <a:spcBef>
-                <a:spcPct val="20000"/>
-              </a:spcBef>
-              <a:spcAft>
-                <a:spcPct val="0"/>
-              </a:spcAft>
-              <a:buFont typeface="Arial" charset="0"/>
-              <a:buNone/>
-              <a:defRPr sz="3392" b="1" kern="1200" baseline="0">
-                <a:solidFill>
-                  <a:schemeClr val="bg1"/>
-                </a:solidFill>
-                <a:latin typeface="+mn-lt"/>
-                <a:ea typeface="ＭＳ Ｐゴシック" charset="-128"/>
-                <a:cs typeface="ＭＳ Ｐゴシック" charset="-128"/>
-              </a:defRPr>
-            </a:lvl1pPr>
-            <a:lvl2pPr marL="3268517" indent="-1255891" algn="l" defTabSz="4022342" rtl="0" eaLnBrk="1" fontAlgn="base" hangingPunct="1">
-              <a:spcBef>
-                <a:spcPct val="20000"/>
-              </a:spcBef>
-              <a:spcAft>
-                <a:spcPct val="0"/>
-              </a:spcAft>
-              <a:buFont typeface="Arial" charset="0"/>
-              <a:buChar char="–"/>
-              <a:defRPr sz="12375" kern="1200">
-                <a:solidFill>
-                  <a:schemeClr val="tx1"/>
-                </a:solidFill>
-                <a:latin typeface="+mn-lt"/>
-                <a:ea typeface="ＭＳ Ｐゴシック" charset="-128"/>
-                <a:cs typeface="+mn-cs"/>
-              </a:defRPr>
-            </a:lvl2pPr>
-            <a:lvl3pPr marL="5027928" indent="-1005586" algn="l" defTabSz="4022342" rtl="0" eaLnBrk="1" fontAlgn="base" hangingPunct="1">
-              <a:spcBef>
-                <a:spcPct val="20000"/>
-              </a:spcBef>
-              <a:spcAft>
-                <a:spcPct val="0"/>
-              </a:spcAft>
-              <a:buFont typeface="Arial" charset="0"/>
-              <a:buChar char="•"/>
-              <a:defRPr sz="10634" kern="1200">
-                <a:solidFill>
-                  <a:schemeClr val="tx1"/>
-                </a:solidFill>
-                <a:latin typeface="+mn-lt"/>
-                <a:ea typeface="ＭＳ Ｐゴシック" charset="-128"/>
-                <a:cs typeface="+mn-cs"/>
-              </a:defRPr>
-            </a:lvl3pPr>
-            <a:lvl4pPr marL="7040554" indent="-1005586" algn="l" defTabSz="4022342" rtl="0" eaLnBrk="1" fontAlgn="base" hangingPunct="1">
-              <a:spcBef>
-                <a:spcPct val="20000"/>
-              </a:spcBef>
-              <a:spcAft>
-                <a:spcPct val="0"/>
-              </a:spcAft>
-              <a:buFont typeface="Arial" charset="0"/>
-              <a:buChar char="–"/>
-              <a:defRPr sz="8800" kern="1200">
-                <a:solidFill>
-                  <a:schemeClr val="tx1"/>
-                </a:solidFill>
-                <a:latin typeface="+mn-lt"/>
-                <a:ea typeface="ＭＳ Ｐゴシック" charset="-128"/>
-                <a:cs typeface="+mn-cs"/>
-              </a:defRPr>
-            </a:lvl4pPr>
-            <a:lvl5pPr marL="9051725" indent="-1005586" algn="l" defTabSz="4022342" rtl="0" eaLnBrk="1" fontAlgn="base" hangingPunct="1">
-              <a:spcBef>
-                <a:spcPct val="20000"/>
-              </a:spcBef>
-              <a:spcAft>
-                <a:spcPct val="0"/>
-              </a:spcAft>
-              <a:buFont typeface="Arial" charset="0"/>
-              <a:buChar char="»"/>
-              <a:defRPr sz="8800" kern="1200">
-                <a:solidFill>
-                  <a:schemeClr val="tx1"/>
-                </a:solidFill>
-                <a:latin typeface="+mn-lt"/>
-                <a:ea typeface="ＭＳ Ｐゴシック" charset="-128"/>
-                <a:cs typeface="+mn-cs"/>
-              </a:defRPr>
-            </a:lvl5pPr>
-            <a:lvl6pPr marL="11064090" indent="-1005827" algn="l" defTabSz="4023305" rtl="0" eaLnBrk="1" latinLnBrk="0" hangingPunct="1">
-              <a:spcBef>
-                <a:spcPct val="20000"/>
-              </a:spcBef>
-              <a:buFont typeface="Arial" pitchFamily="34" charset="0"/>
-              <a:buChar char="•"/>
-              <a:defRPr sz="8800" kern="1200">
-                <a:solidFill>
-                  <a:schemeClr val="tx1"/>
-                </a:solidFill>
-                <a:latin typeface="+mn-lt"/>
-                <a:ea typeface="+mn-ea"/>
-                <a:cs typeface="+mn-cs"/>
-              </a:defRPr>
-            </a:lvl6pPr>
-            <a:lvl7pPr marL="13075741" indent="-1005827" algn="l" defTabSz="4023305" rtl="0" eaLnBrk="1" latinLnBrk="0" hangingPunct="1">
-              <a:spcBef>
-                <a:spcPct val="20000"/>
-              </a:spcBef>
-              <a:buFont typeface="Arial" pitchFamily="34" charset="0"/>
-              <a:buChar char="•"/>
-              <a:defRPr sz="8800" kern="1200">
-                <a:solidFill>
-                  <a:schemeClr val="tx1"/>
-                </a:solidFill>
-                <a:latin typeface="+mn-lt"/>
-                <a:ea typeface="+mn-ea"/>
-                <a:cs typeface="+mn-cs"/>
-              </a:defRPr>
-            </a:lvl7pPr>
-            <a:lvl8pPr marL="15087394" indent="-1005827" algn="l" defTabSz="4023305" rtl="0" eaLnBrk="1" latinLnBrk="0" hangingPunct="1">
-              <a:spcBef>
-                <a:spcPct val="20000"/>
-              </a:spcBef>
-              <a:buFont typeface="Arial" pitchFamily="34" charset="0"/>
-              <a:buChar char="•"/>
-              <a:defRPr sz="8800" kern="1200">
-                <a:solidFill>
-                  <a:schemeClr val="tx1"/>
-                </a:solidFill>
-                <a:latin typeface="+mn-lt"/>
-                <a:ea typeface="+mn-ea"/>
-                <a:cs typeface="+mn-cs"/>
-              </a:defRPr>
-            </a:lvl8pPr>
-            <a:lvl9pPr marL="17099047" indent="-1005827" algn="l" defTabSz="4023305" rtl="0" eaLnBrk="1" latinLnBrk="0" hangingPunct="1">
-              <a:spcBef>
-                <a:spcPct val="20000"/>
-              </a:spcBef>
-              <a:buFont typeface="Arial" pitchFamily="34" charset="0"/>
-              <a:buChar char="•"/>
-              <a:defRPr sz="8800" kern="1200">
-                <a:solidFill>
-                  <a:schemeClr val="tx1"/>
-                </a:solidFill>
-                <a:latin typeface="+mn-lt"/>
-                <a:ea typeface="+mn-ea"/>
-                <a:cs typeface="+mn-cs"/>
-              </a:defRPr>
-            </a:lvl9pPr>
-          </a:lstStyle>
-          <a:p>
-            <a:r>
-              <a:rPr lang="en-US" dirty="0"/>
-              <a:t>Analysis</a:t>
-            </a:r>
-          </a:p>
-        </p:txBody>
-      </p:sp>
-      <p:sp>
-        <p:nvSpPr>
           <p:cNvPr id="7" name="Text Placeholder 55">
             <a:extLst>
               <a:ext uri="{FF2B5EF4-FFF2-40B4-BE49-F238E27FC236}">
@@ -9748,7 +9993,7 @@
         </p:nvSpPr>
         <p:spPr>
           <a:xfrm>
-            <a:off x="22635765" y="31020171"/>
+            <a:off x="22610437" y="32659404"/>
             <a:ext cx="6907325" cy="891334"/>
           </a:xfrm>
           <a:prstGeom prst="rect">
@@ -9922,6 +10167,403 @@
           </a:p>
         </p:txBody>
       </p:sp>
+      <p:pic>
+        <p:nvPicPr>
+          <p:cNvPr id="9" name="Picture 8">
+            <a:extLst>
+              <a:ext uri="{FF2B5EF4-FFF2-40B4-BE49-F238E27FC236}">
+                <a16:creationId xmlns:a16="http://schemas.microsoft.com/office/drawing/2014/main" id="{76058962-DD50-1B29-F87D-FB32DCC7A696}"/>
+              </a:ext>
+            </a:extLst>
+          </p:cNvPr>
+          <p:cNvPicPr>
+            <a:picLocks noChangeAspect="1"/>
+          </p:cNvPicPr>
+          <p:nvPr/>
+        </p:nvPicPr>
+        <p:blipFill>
+          <a:blip r:embed="rId2"/>
+          <a:stretch>
+            <a:fillRect/>
+          </a:stretch>
+        </p:blipFill>
+        <p:spPr>
+          <a:xfrm>
+            <a:off x="8011771" y="9042768"/>
+            <a:ext cx="19125533" cy="5318222"/>
+          </a:xfrm>
+          <a:prstGeom prst="rect">
+            <a:avLst/>
+          </a:prstGeom>
+        </p:spPr>
+      </p:pic>
+      <p:sp>
+        <p:nvSpPr>
+          <p:cNvPr id="12" name="Text Placeholder 48">
+            <a:extLst>
+              <a:ext uri="{FF2B5EF4-FFF2-40B4-BE49-F238E27FC236}">
+                <a16:creationId xmlns:a16="http://schemas.microsoft.com/office/drawing/2014/main" id="{1A077120-A6AD-BC11-19CC-FE78459359E7}"/>
+              </a:ext>
+            </a:extLst>
+          </p:cNvPr>
+          <p:cNvSpPr txBox="1">
+            <a:spLocks/>
+          </p:cNvSpPr>
+          <p:nvPr/>
+        </p:nvSpPr>
+        <p:spPr>
+          <a:xfrm>
+            <a:off x="7966174" y="29225125"/>
+            <a:ext cx="14246124" cy="891334"/>
+          </a:xfrm>
+          <a:prstGeom prst="rect">
+            <a:avLst/>
+          </a:prstGeom>
+          <a:solidFill>
+            <a:schemeClr val="accent1"/>
+          </a:solidFill>
+        </p:spPr>
+        <p:txBody>
+          <a:bodyPr wrap="square" lIns="182880" tIns="182880" rIns="182880" bIns="182880" anchor="ctr" anchorCtr="0">
+            <a:spAutoFit/>
+          </a:bodyPr>
+          <a:lstStyle>
+            <a:lvl1pPr marL="1507651" indent="-1507651" algn="ctr" defTabSz="4022342" rtl="0" eaLnBrk="1" fontAlgn="base" hangingPunct="1">
+              <a:spcBef>
+                <a:spcPct val="20000"/>
+              </a:spcBef>
+              <a:spcAft>
+                <a:spcPct val="0"/>
+              </a:spcAft>
+              <a:buFont typeface="Arial" charset="0"/>
+              <a:buNone/>
+              <a:defRPr sz="3392" b="1" kern="1200" baseline="0">
+                <a:solidFill>
+                  <a:schemeClr val="bg1"/>
+                </a:solidFill>
+                <a:latin typeface="+mn-lt"/>
+                <a:ea typeface="ＭＳ Ｐゴシック" charset="-128"/>
+                <a:cs typeface="ＭＳ Ｐゴシック" charset="-128"/>
+              </a:defRPr>
+            </a:lvl1pPr>
+            <a:lvl2pPr marL="3268517" indent="-1255891" algn="l" defTabSz="4022342" rtl="0" eaLnBrk="1" fontAlgn="base" hangingPunct="1">
+              <a:spcBef>
+                <a:spcPct val="20000"/>
+              </a:spcBef>
+              <a:spcAft>
+                <a:spcPct val="0"/>
+              </a:spcAft>
+              <a:buFont typeface="Arial" charset="0"/>
+              <a:buChar char="–"/>
+              <a:defRPr sz="12375" kern="1200">
+                <a:solidFill>
+                  <a:schemeClr val="tx1"/>
+                </a:solidFill>
+                <a:latin typeface="+mn-lt"/>
+                <a:ea typeface="ＭＳ Ｐゴシック" charset="-128"/>
+                <a:cs typeface="+mn-cs"/>
+              </a:defRPr>
+            </a:lvl2pPr>
+            <a:lvl3pPr marL="5027928" indent="-1005586" algn="l" defTabSz="4022342" rtl="0" eaLnBrk="1" fontAlgn="base" hangingPunct="1">
+              <a:spcBef>
+                <a:spcPct val="20000"/>
+              </a:spcBef>
+              <a:spcAft>
+                <a:spcPct val="0"/>
+              </a:spcAft>
+              <a:buFont typeface="Arial" charset="0"/>
+              <a:buChar char="•"/>
+              <a:defRPr sz="10634" kern="1200">
+                <a:solidFill>
+                  <a:schemeClr val="tx1"/>
+                </a:solidFill>
+                <a:latin typeface="+mn-lt"/>
+                <a:ea typeface="ＭＳ Ｐゴシック" charset="-128"/>
+                <a:cs typeface="+mn-cs"/>
+              </a:defRPr>
+            </a:lvl3pPr>
+            <a:lvl4pPr marL="7040554" indent="-1005586" algn="l" defTabSz="4022342" rtl="0" eaLnBrk="1" fontAlgn="base" hangingPunct="1">
+              <a:spcBef>
+                <a:spcPct val="20000"/>
+              </a:spcBef>
+              <a:spcAft>
+                <a:spcPct val="0"/>
+              </a:spcAft>
+              <a:buFont typeface="Arial" charset="0"/>
+              <a:buChar char="–"/>
+              <a:defRPr sz="8800" kern="1200">
+                <a:solidFill>
+                  <a:schemeClr val="tx1"/>
+                </a:solidFill>
+                <a:latin typeface="+mn-lt"/>
+                <a:ea typeface="ＭＳ Ｐゴシック" charset="-128"/>
+                <a:cs typeface="+mn-cs"/>
+              </a:defRPr>
+            </a:lvl4pPr>
+            <a:lvl5pPr marL="9051725" indent="-1005586" algn="l" defTabSz="4022342" rtl="0" eaLnBrk="1" fontAlgn="base" hangingPunct="1">
+              <a:spcBef>
+                <a:spcPct val="20000"/>
+              </a:spcBef>
+              <a:spcAft>
+                <a:spcPct val="0"/>
+              </a:spcAft>
+              <a:buFont typeface="Arial" charset="0"/>
+              <a:buChar char="»"/>
+              <a:defRPr sz="8800" kern="1200">
+                <a:solidFill>
+                  <a:schemeClr val="tx1"/>
+                </a:solidFill>
+                <a:latin typeface="+mn-lt"/>
+                <a:ea typeface="ＭＳ Ｐゴシック" charset="-128"/>
+                <a:cs typeface="+mn-cs"/>
+              </a:defRPr>
+            </a:lvl5pPr>
+            <a:lvl6pPr marL="11064090" indent="-1005827" algn="l" defTabSz="4023305" rtl="0" eaLnBrk="1" latinLnBrk="0" hangingPunct="1">
+              <a:spcBef>
+                <a:spcPct val="20000"/>
+              </a:spcBef>
+              <a:buFont typeface="Arial" pitchFamily="34" charset="0"/>
+              <a:buChar char="•"/>
+              <a:defRPr sz="8800" kern="1200">
+                <a:solidFill>
+                  <a:schemeClr val="tx1"/>
+                </a:solidFill>
+                <a:latin typeface="+mn-lt"/>
+                <a:ea typeface="+mn-ea"/>
+                <a:cs typeface="+mn-cs"/>
+              </a:defRPr>
+            </a:lvl6pPr>
+            <a:lvl7pPr marL="13075741" indent="-1005827" algn="l" defTabSz="4023305" rtl="0" eaLnBrk="1" latinLnBrk="0" hangingPunct="1">
+              <a:spcBef>
+                <a:spcPct val="20000"/>
+              </a:spcBef>
+              <a:buFont typeface="Arial" pitchFamily="34" charset="0"/>
+              <a:buChar char="•"/>
+              <a:defRPr sz="8800" kern="1200">
+                <a:solidFill>
+                  <a:schemeClr val="tx1"/>
+                </a:solidFill>
+                <a:latin typeface="+mn-lt"/>
+                <a:ea typeface="+mn-ea"/>
+                <a:cs typeface="+mn-cs"/>
+              </a:defRPr>
+            </a:lvl7pPr>
+            <a:lvl8pPr marL="15087394" indent="-1005827" algn="l" defTabSz="4023305" rtl="0" eaLnBrk="1" latinLnBrk="0" hangingPunct="1">
+              <a:spcBef>
+                <a:spcPct val="20000"/>
+              </a:spcBef>
+              <a:buFont typeface="Arial" pitchFamily="34" charset="0"/>
+              <a:buChar char="•"/>
+              <a:defRPr sz="8800" kern="1200">
+                <a:solidFill>
+                  <a:schemeClr val="tx1"/>
+                </a:solidFill>
+                <a:latin typeface="+mn-lt"/>
+                <a:ea typeface="+mn-ea"/>
+                <a:cs typeface="+mn-cs"/>
+              </a:defRPr>
+            </a:lvl8pPr>
+            <a:lvl9pPr marL="17099047" indent="-1005827" algn="l" defTabSz="4023305" rtl="0" eaLnBrk="1" latinLnBrk="0" hangingPunct="1">
+              <a:spcBef>
+                <a:spcPct val="20000"/>
+              </a:spcBef>
+              <a:buFont typeface="Arial" pitchFamily="34" charset="0"/>
+              <a:buChar char="•"/>
+              <a:defRPr sz="8800" kern="1200">
+                <a:solidFill>
+                  <a:schemeClr val="tx1"/>
+                </a:solidFill>
+                <a:latin typeface="+mn-lt"/>
+                <a:ea typeface="+mn-ea"/>
+                <a:cs typeface="+mn-cs"/>
+              </a:defRPr>
+            </a:lvl9pPr>
+          </a:lstStyle>
+          <a:p>
+            <a:r>
+              <a:rPr lang="en-US" dirty="0"/>
+              <a:t>Magnetic Field Results</a:t>
+            </a:r>
+          </a:p>
+        </p:txBody>
+      </p:sp>
+      <p:pic>
+        <p:nvPicPr>
+          <p:cNvPr id="66" name="Picture Placeholder 65">
+            <a:extLst>
+              <a:ext uri="{FF2B5EF4-FFF2-40B4-BE49-F238E27FC236}">
+                <a16:creationId xmlns:a16="http://schemas.microsoft.com/office/drawing/2014/main" id="{BA2D61E0-3344-A154-AD6E-EDEC62D598C8}"/>
+              </a:ext>
+            </a:extLst>
+          </p:cNvPr>
+          <p:cNvPicPr>
+            <a:picLocks noGrp="1" noChangeAspect="1"/>
+          </p:cNvPicPr>
+          <p:nvPr>
+            <p:ph type="pic" sz="quarter" idx="152"/>
+          </p:nvPr>
+        </p:nvPicPr>
+        <p:blipFill>
+          <a:blip r:embed="rId3" cstate="email">
+            <a:extLst>
+              <a:ext uri="{28A0092B-C50C-407E-A947-70E740481C1C}">
+                <a14:useLocalDpi xmlns:a14="http://schemas.microsoft.com/office/drawing/2010/main" val="0"/>
+              </a:ext>
+            </a:extLst>
+          </a:blip>
+          <a:stretch>
+            <a:fillRect/>
+          </a:stretch>
+        </p:blipFill>
+        <p:spPr>
+          <a:xfrm>
+            <a:off x="374854" y="22428188"/>
+            <a:ext cx="7196643" cy="5397482"/>
+          </a:xfrm>
+          <a:prstGeom prst="rect">
+            <a:avLst/>
+          </a:prstGeom>
+        </p:spPr>
+      </p:pic>
+      <p:sp>
+        <p:nvSpPr>
+          <p:cNvPr id="73" name="Picture Placeholder 72">
+            <a:extLst>
+              <a:ext uri="{FF2B5EF4-FFF2-40B4-BE49-F238E27FC236}">
+                <a16:creationId xmlns:a16="http://schemas.microsoft.com/office/drawing/2014/main" id="{6807D8E6-3A59-B597-56E9-E1CBF71AD2AF}"/>
+              </a:ext>
+            </a:extLst>
+          </p:cNvPr>
+          <p:cNvSpPr>
+            <a:spLocks noGrp="1"/>
+          </p:cNvSpPr>
+          <p:nvPr>
+            <p:ph type="pic" sz="quarter" idx="153"/>
+          </p:nvPr>
+        </p:nvSpPr>
+        <p:spPr/>
+      </p:sp>
+      <p:pic>
+        <p:nvPicPr>
+          <p:cNvPr id="75" name="Picture 74">
+            <a:extLst>
+              <a:ext uri="{FF2B5EF4-FFF2-40B4-BE49-F238E27FC236}">
+                <a16:creationId xmlns:a16="http://schemas.microsoft.com/office/drawing/2014/main" id="{924EFD0C-0554-E865-5AD3-BD6183A70793}"/>
+              </a:ext>
+            </a:extLst>
+          </p:cNvPr>
+          <p:cNvPicPr>
+            <a:picLocks noChangeAspect="1"/>
+          </p:cNvPicPr>
+          <p:nvPr/>
+        </p:nvPicPr>
+        <p:blipFill>
+          <a:blip r:embed="rId4"/>
+          <a:stretch>
+            <a:fillRect/>
+          </a:stretch>
+        </p:blipFill>
+        <p:spPr>
+          <a:xfrm>
+            <a:off x="15713313" y="19939262"/>
+            <a:ext cx="6450066" cy="4500046"/>
+          </a:xfrm>
+          <a:prstGeom prst="rect">
+            <a:avLst/>
+          </a:prstGeom>
+        </p:spPr>
+      </p:pic>
+      <p:pic>
+        <p:nvPicPr>
+          <p:cNvPr id="80" name="Picture 79">
+            <a:extLst>
+              <a:ext uri="{FF2B5EF4-FFF2-40B4-BE49-F238E27FC236}">
+                <a16:creationId xmlns:a16="http://schemas.microsoft.com/office/drawing/2014/main" id="{6CD9DFBF-2CE8-7198-8B0D-15737B9144F3}"/>
+              </a:ext>
+            </a:extLst>
+          </p:cNvPr>
+          <p:cNvPicPr>
+            <a:picLocks noChangeAspect="1"/>
+          </p:cNvPicPr>
+          <p:nvPr/>
+        </p:nvPicPr>
+        <p:blipFill>
+          <a:blip r:embed="rId5"/>
+          <a:stretch>
+            <a:fillRect/>
+          </a:stretch>
+        </p:blipFill>
+        <p:spPr>
+          <a:xfrm>
+            <a:off x="7922472" y="24433397"/>
+            <a:ext cx="7244964" cy="4517303"/>
+          </a:xfrm>
+          <a:prstGeom prst="rect">
+            <a:avLst/>
+          </a:prstGeom>
+        </p:spPr>
+      </p:pic>
+      <p:graphicFrame>
+        <p:nvGraphicFramePr>
+          <p:cNvPr id="81" name="Chart 80">
+            <a:extLst>
+              <a:ext uri="{FF2B5EF4-FFF2-40B4-BE49-F238E27FC236}">
+                <a16:creationId xmlns:a16="http://schemas.microsoft.com/office/drawing/2014/main" id="{2AB1109F-AB73-485A-A314-30F0F4BC0549}"/>
+              </a:ext>
+            </a:extLst>
+          </p:cNvPr>
+          <p:cNvGraphicFramePr>
+            <a:graphicFrameLocks/>
+          </p:cNvGraphicFramePr>
+          <p:nvPr>
+            <p:extLst>
+              <p:ext uri="{D42A27DB-BD31-4B8C-83A1-F6EECF244321}">
+                <p14:modId xmlns:p14="http://schemas.microsoft.com/office/powerpoint/2010/main" val="305714622"/>
+              </p:ext>
+            </p:extLst>
+          </p:nvPr>
+        </p:nvGraphicFramePr>
+        <p:xfrm>
+          <a:off x="8405676" y="20104470"/>
+          <a:ext cx="6139039" cy="4169630"/>
+        </p:xfrm>
+        <a:graphic>
+          <a:graphicData uri="http://schemas.openxmlformats.org/drawingml/2006/chart">
+            <c:chart xmlns:c="http://schemas.openxmlformats.org/drawingml/2006/chart" xmlns:r="http://schemas.openxmlformats.org/officeDocument/2006/relationships" r:id="rId6"/>
+          </a:graphicData>
+        </a:graphic>
+      </p:graphicFrame>
+      <p:pic>
+        <p:nvPicPr>
+          <p:cNvPr id="83" name="Picture 82">
+            <a:extLst>
+              <a:ext uri="{FF2B5EF4-FFF2-40B4-BE49-F238E27FC236}">
+                <a16:creationId xmlns:a16="http://schemas.microsoft.com/office/drawing/2014/main" id="{263E0FAB-8368-3B95-5532-AD2E86604F38}"/>
+              </a:ext>
+            </a:extLst>
+          </p:cNvPr>
+          <p:cNvPicPr>
+            <a:picLocks noChangeAspect="1"/>
+          </p:cNvPicPr>
+          <p:nvPr/>
+        </p:nvPicPr>
+        <p:blipFill>
+          <a:blip r:embed="rId7"/>
+          <a:srcRect l="7464" t="34881" r="4078" b="42447"/>
+          <a:stretch>
+            <a:fillRect/>
+          </a:stretch>
+        </p:blipFill>
+        <p:spPr>
+          <a:xfrm>
+            <a:off x="17621167" y="14466092"/>
+            <a:ext cx="11896595" cy="2287806"/>
+          </a:xfrm>
+          <a:prstGeom prst="rect">
+            <a:avLst/>
+          </a:prstGeom>
+        </p:spPr>
+      </p:pic>
     </p:spTree>
   </p:cSld>
   <p:clrMapOvr>

</xml_diff>